<commit_message>
Sederhanakan kalimat aturan kalibrasi (slide 1/2)
Co-Authored-By: Claude Opus 5.5 <noreply@anthropic.com>
Claude-Session: https://claude.ai/code/session_01RwTK1q8JkWDwXbpfgwmLot
</commit_message>
<xml_diff>
--- a/Slide - Kalibrasi (2 slide).pptx
+++ b/Slide - Kalibrasi (2 slide).pptx
@@ -6591,7 +6591,7 @@
                 </a:solidFill>
                 <a:latin typeface="Calibri (MS) Bold"/>
               </a:rPr>
-              <a:t>Rentang pencarian punya dasar</a:t>
+              <a:t>Nilai yang dicoba punya batas yang jelas</a:t>
             </a:r>
           </a:p>
           <a:p>
@@ -6607,7 +6607,7 @@
                 </a:solidFill>
                 <a:latin typeface="Calibri (MS)"/>
               </a:rPr>
-              <a:t>Diambil dari beberapa rujukan, atau dari selang kepercayaan 95% hasil estimasi tren.</a:t>
+              <a:t>Batasnya diambil dari rujukan, atau dari selang kepercayaan 95% saat parameter dihitung dari data. Contoh: laju konversi lahan dicoba 0,0034–0,0851.</a:t>
             </a:r>
           </a:p>
         </p:txBody>
@@ -6725,7 +6725,7 @@
                 </a:solidFill>
                 <a:latin typeface="Calibri (MS) Bold"/>
               </a:rPr>
-              <a:t>Parameter berpasangan dihitung ulang</a:t>
+              <a:t>Parameter yang saling terkait ikut disesuaikan</a:t>
             </a:r>
           </a:p>
           <a:p>
@@ -6741,7 +6741,7 @@
                 </a:solidFill>
                 <a:latin typeface="Calibri (MS)"/>
               </a:rPr>
-              <a:t>Setiap nilai yang dicoba, pasangannya dihitung ulang dengan persamaan stok-aliran agar tetap sesuai data historis.</a:t>
+              <a:t>Contoh: setiap kali batas TPK diubah, sensitivitas konstruksi dihitung ulang agar model tetap sesuai data tahun dasar.</a:t>
             </a:r>
           </a:p>
         </p:txBody>
@@ -6993,7 +6993,7 @@
                 </a:solidFill>
                 <a:latin typeface="Calibri (MS) Bold"/>
               </a:rPr>
-              <a:t>Batas "sama baiknya" 5%</a:t>
+              <a:t>Selisih kecil dianggap setara (batas 5%)</a:t>
             </a:r>
           </a:p>
           <a:p>
@@ -7009,7 +7009,7 @@
                 </a:solidFill>
                 <a:latin typeface="Calibri (MS)"/>
               </a:rPr>
-              <a:t>Semua nilai yang hasilnya paling buruk 5% di atas nilai terbaik dianggap sama baiknya.</a:t>
+              <a:t>Nilai yang NRMSE-nya paling banyak 5% di atas nilai terbaik dianggap sama baiknya. Contoh: terbaik 0,100 → nilai dengan NRMSE ≤ 0,105 setara.</a:t>
             </a:r>
           </a:p>
         </p:txBody>
@@ -7092,7 +7092,7 @@
         </p:nvGraphicFramePr>
         <p:xfrm>
           <a:off x="9281160" y="2286000"/>
-          <a:ext cx="8183880" cy="3291840"/>
+          <a:ext cx="8183880" cy="3566160"/>
         </p:xfrm>
         <a:graphic>
           <a:graphicData uri="http://schemas.openxmlformats.org/drawingml/2006/table">
@@ -7105,7 +7105,7 @@
                 <a:gridCol w="3291840"/>
                 <a:gridCol w="4434840"/>
               </a:tblGrid>
-              <a:tr h="658368">
+              <a:tr h="713232">
                 <a:tc>
                   <a:txBody>
                     <a:bodyPr wrap="square"/>
@@ -7173,7 +7173,7 @@
                   </a:tcPr>
                 </a:tc>
               </a:tr>
-              <a:tr h="658368">
+              <a:tr h="713232">
                 <a:tc>
                   <a:txBody>
                     <a:bodyPr wrap="square"/>
@@ -7209,7 +7209,7 @@
                           </a:solidFill>
                           <a:latin typeface="Calibri (MS)"/>
                         </a:rPr>
-                        <a:t>Nilai dari data termasuk kelompok "sama baiknya"</a:t>
+                        <a:t>Nilai dari data sudah termasuk yang sama baiknya (≤ 5% di atas nilai terbaik)</a:t>
                       </a:r>
                     </a:p>
                   </a:txBody>
@@ -7231,7 +7231,7 @@
                           </a:solidFill>
                           <a:latin typeface="Calibri (MS)"/>
                         </a:rPr>
-                        <a:t>Perbaikannya tidak berarti → nilai dari data dipertahankan</a:t>
+                        <a:t>Tidak diganti, karena nilai baru tidak lebih baik secara berarti</a:t>
                       </a:r>
                     </a:p>
                   </a:txBody>
@@ -7242,7 +7242,7 @@
                   </a:tcPr>
                 </a:tc>
               </a:tr>
-              <a:tr h="658368">
+              <a:tr h="713232">
                 <a:tc>
                   <a:txBody>
                     <a:bodyPr wrap="square"/>
@@ -7278,7 +7278,7 @@
                           </a:solidFill>
                           <a:latin typeface="Calibri (MS)"/>
                         </a:rPr>
-                        <a:t>Kelompok "sama baiknya" membentang dari ujung ke ujung rentang</a:t>
+                        <a:t>Nilai yang sama baiknya tersebar dari ujung bawah sampai ujung atas batas</a:t>
                       </a:r>
                     </a:p>
                   </a:txBody>
@@ -7300,7 +7300,7 @@
                           </a:solidFill>
                           <a:latin typeface="Calibri (MS)"/>
                         </a:rPr>
-                        <a:t>Data tidak bisa menentukan nilainya → nilai dari data dipertahankan</a:t>
+                        <a:t>Data tidak bisa menunjuk satu nilai → nilai dari data tetap dipakai</a:t>
                       </a:r>
                     </a:p>
                   </a:txBody>
@@ -7311,7 +7311,7 @@
                   </a:tcPr>
                 </a:tc>
               </a:tr>
-              <a:tr h="658368">
+              <a:tr h="713232">
                 <a:tc>
                   <a:txBody>
                     <a:bodyPr wrap="square"/>
@@ -7347,7 +7347,7 @@
                           </a:solidFill>
                           <a:latin typeface="Calibri (MS)"/>
                         </a:rPr>
-                        <a:t>Nilai terbaik tepat di batas rentang</a:t>
+                        <a:t>Nilai terbaik jatuh tepat di batas yang dicoba</a:t>
                       </a:r>
                     </a:p>
                   </a:txBody>
@@ -7369,7 +7369,7 @@
                           </a:solidFill>
                           <a:latin typeface="Calibri (MS)"/>
                         </a:rPr>
-                        <a:t>Diperiksa ulang: tiap tahun dikeluarkan satu per satu, apakah satu tahun saja yang menariknya?</a:t>
+                        <a:t>Dicek ulang dengan membuang satu tahun data secara bergantian: apakah nilai terbaik hanya muncul karena satu tahun yang janggal?</a:t>
                       </a:r>
                     </a:p>
                   </a:txBody>
@@ -7380,7 +7380,7 @@
                   </a:tcPr>
                 </a:tc>
               </a:tr>
-              <a:tr h="658368">
+              <a:tr h="713232">
                 <a:tc>
                   <a:txBody>
                     <a:bodyPr wrap="square"/>
@@ -7416,7 +7416,7 @@
                           </a:solidFill>
                           <a:latin typeface="Calibri (MS)"/>
                         </a:rPr>
-                        <a:t>Selain ketiga kondisi di atas</a:t>
+                        <a:t>Tidak termasuk ketiga kondisi di atas</a:t>
                       </a:r>
                     </a:p>
                   </a:txBody>
@@ -7438,7 +7438,7 @@
                           </a:solidFill>
                           <a:latin typeface="Calibri (MS)"/>
                         </a:rPr>
-                        <a:t>Nilai terbaik dipakai, asalkan lolos uji kompatibilitas (Tahap 4)</a:t>
+                        <a:t>Nilai terbaik dipakai, tetapi harus lolos uji pada model penuh (Tahap 4)</a:t>
                       </a:r>
                     </a:p>
                   </a:txBody>
@@ -7461,8 +7461,8 @@
         </p:nvSpPr>
         <p:spPr>
           <a:xfrm>
-            <a:off x="9281160" y="5715000"/>
-            <a:ext cx="8183879" cy="1965960"/>
+            <a:off x="9281160" y="6035040"/>
+            <a:ext cx="8183879" cy="1691640"/>
           </a:xfrm>
           <a:prstGeom prst="roundRect">
             <a:avLst>
@@ -7512,13 +7512,13 @@
               <a:t>Uji kompatibilitas (Tahap 4): </a:t>
             </a:r>
             <a:r>
-              <a:rPr sz="1260" b="0" i="0">
+              <a:rPr sz="1210" b="0" i="0">
                 <a:solidFill>
                   <a:srgbClr val="14313B"/>
                 </a:solidFill>
                 <a:latin typeface="Calibri (MS)"/>
               </a:rPr>
-              <a:t>hasil kalibrasi dicoba pada model penuh dan ditolak bila</a:t>
+              <a:t>nilai hasil kalibrasi dicoba pada model penuh (semua subsistem aktif), dan ditolak bila salah satu terjadi:</a:t>
             </a:r>
           </a:p>
           <a:p>
@@ -7527,6 +7527,15 @@
                 <a:spcPts val="300"/>
               </a:spcAft>
             </a:pPr>
+            <a:r>
+              <a:rPr sz="1210" b="0" i="0">
+                <a:solidFill>
+                  <a:srgbClr val="14313B"/>
+                </a:solidFill>
+                <a:latin typeface="Calibri (MS)"/>
+              </a:rPr>
+              <a:t>•  kecocokan variabel yang dikalibrasi memburuk lebih dari 5% </a:t>
+            </a:r>
             <a:r>
               <a:rPr sz="1210" b="1" i="0">
                 <a:solidFill>
@@ -7534,8 +7543,15 @@
                 </a:solidFill>
                 <a:latin typeface="Calibri (MS) Bold"/>
               </a:rPr>
-              <a:t>M1  </a:t>
-            </a:r>
+              <a:t>(M1)</a:t>
+            </a:r>
+          </a:p>
+          <a:p>
+            <a:pPr algn="l">
+              <a:spcAft>
+                <a:spcPts val="300"/>
+              </a:spcAft>
+            </a:pPr>
             <a:r>
               <a:rPr sz="1210" b="0" i="0">
                 <a:solidFill>
@@ -7543,15 +7559,8 @@
                 </a:solidFill>
                 <a:latin typeface="Calibri (MS)"/>
               </a:rPr>
-              <a:t>NRMSE variabel sasaran memburuk lebih dari 5%</a:t>
-            </a:r>
-          </a:p>
-          <a:p>
-            <a:pPr algn="l">
-              <a:spcAft>
-                <a:spcPts val="300"/>
-              </a:spcAft>
-            </a:pPr>
+              <a:t>•  rata-rata kecocokan 9 variabel memburuk lebih dari 5% </a:t>
+            </a:r>
             <a:r>
               <a:rPr sz="1210" b="1" i="0">
                 <a:solidFill>
@@ -7559,8 +7568,15 @@
                 </a:solidFill>
                 <a:latin typeface="Calibri (MS) Bold"/>
               </a:rPr>
-              <a:t>M2  </a:t>
-            </a:r>
+              <a:t>(M2)</a:t>
+            </a:r>
+          </a:p>
+          <a:p>
+            <a:pPr algn="l">
+              <a:spcAft>
+                <a:spcPts val="300"/>
+              </a:spcAft>
+            </a:pPr>
             <a:r>
               <a:rPr sz="1210" b="0" i="0">
                 <a:solidFill>
@@ -7568,15 +7584,8 @@
                 </a:solidFill>
                 <a:latin typeface="Calibri (MS)"/>
               </a:rPr>
-              <a:t>rata-rata NRMSE 9 variabel memburuk lebih dari 5%</a:t>
-            </a:r>
-          </a:p>
-          <a:p>
-            <a:pPr algn="l">
-              <a:spcAft>
-                <a:spcPts val="300"/>
-              </a:spcAft>
-            </a:pPr>
+              <a:t>•  model gagal pada uji kondisi ekstrem </a:t>
+            </a:r>
             <a:r>
               <a:rPr sz="1210" b="1" i="0">
                 <a:solidFill>
@@ -7584,7 +7593,7 @@
                 </a:solidFill>
                 <a:latin typeface="Calibri (MS) Bold"/>
               </a:rPr>
-              <a:t>S  </a:t>
+              <a:t>(S)</a:t>
             </a:r>
             <a:r>
               <a:rPr sz="1210" b="0" i="0">
@@ -7593,15 +7602,8 @@
                 </a:solidFill>
                 <a:latin typeface="Calibri (MS)"/>
               </a:rPr>
-              <a:t>uji kondisi ekstrem menjadi gagal</a:t>
-            </a:r>
-          </a:p>
-          <a:p>
-            <a:pPr algn="l">
-              <a:spcAft>
-                <a:spcPts val="300"/>
-              </a:spcAft>
-            </a:pPr>
+              <a:t>  •  simulasi jangka panjang tidak stabil </a:t>
+            </a:r>
             <a:r>
               <a:rPr sz="1210" b="1" i="0">
                 <a:solidFill>
@@ -7609,16 +7611,7 @@
                 </a:solidFill>
                 <a:latin typeface="Calibri (MS) Bold"/>
               </a:rPr>
-              <a:t>T  </a:t>
-            </a:r>
-            <a:r>
-              <a:rPr sz="1210" b="0" i="0">
-                <a:solidFill>
-                  <a:srgbClr val="14313B"/>
-                </a:solidFill>
-                <a:latin typeface="Calibri (MS)"/>
-              </a:rPr>
-              <a:t>simulasi jangka panjang menjadi tidak stabil</a:t>
+              <a:t>(T)</a:t>
             </a:r>
           </a:p>
         </p:txBody>
@@ -7657,7 +7650,7 @@
                 </a:solidFill>
                 <a:latin typeface="Calibri (MS)"/>
               </a:rPr>
-              <a:t>Batas 5% ditetapkan peneliti secara terbuka; kepekaannya diperiksa pada 2% dan 10%.</a:t>
+              <a:t>M1, M2, S, T = kode pada Tabel 20 buku. Batas 5% juga dicek pada 2% dan 10%.</a:t>
             </a:r>
           </a:p>
         </p:txBody>
@@ -7727,7 +7720,7 @@
                 </a:solidFill>
                 <a:latin typeface="Calibri (MS)"/>
               </a:rPr>
-              <a:t>Nilai dari data hanya diganti bila perbaikannya nyata, tidak bergantung pada satu tahun saja, dan tetap berlaku di model penuh.</a:t>
+              <a:t>Nilai dari data baru diganti bila nilai baru jelas lebih cocok, tidak hanya karena satu tahun data, dan tetap cocok saat semua subsistem dijalankan bersama.</a:t>
             </a:r>
           </a:p>
         </p:txBody>

</xml_diff>